<commit_message>
Mettre a jour PPTX : cause racine = Fornari, sans mention n_hill
- Slide 5 : reformule comme limitation du modele Fornari
  (terme kill lineaire sans seuil, concu pour carboplatin)
  Suppression de toute reference a n_hill
- Slide 6 etape 3 : adapter Fornari pour ADC longue T½
  (modifier terme kill, ajouter seuil Damage effectif)
- Slide 7 resume : formulation mise a jour

https://claude.ai/code/session_01LRQofhjhvxSvgMrvYoaEon
</commit_message>
<xml_diff>
--- a/scripts_tdxd/results_PKPD_human/TDXd_PKPD_Bilan.pptx
+++ b/scripts_tdxd/results_PKPD_human/TDXd_PKPD_Bilan.pptx
@@ -7842,7 +7842,7 @@
                   <a:srgbClr val="1A3A5C"/>
                 </a:solidFill>
               </a:rPr>
-              <a:t>Cause Racine : Pourquoi 100% Tout Grade ?</a:t>
+              <a:t>Cause Racine : Limitation du Modele Fornari</a:t>
             </a:r>
           </a:p>
         </p:txBody>
@@ -7919,7 +7919,7 @@
                   <a:srgbClr val="B2182B"/>
                 </a:solidFill>
               </a:rPr>
-              <a:t>Probleme fondamental : T½ ADC ≈ 23 jours  &gt;  Intervalle Q3W = 21 jours</a:t>
+              <a:t>Limite structurelle : le modele Fornari predit un effet pour tout Damage &gt; 0</a:t>
             </a:r>
           </a:p>
         </p:txBody>
@@ -7933,7 +7933,7 @@
         <p:spPr>
           <a:xfrm>
             <a:off x="457200" y="1508760"/>
-            <a:ext cx="10972800" cy="2011680"/>
+            <a:ext cx="10972800" cy="2103120"/>
           </a:xfrm>
           <a:prstGeom prst="rect">
             <a:avLst/>
@@ -7978,7 +7978,7 @@
         <p:spPr>
           <a:xfrm>
             <a:off x="640080" y="1554480"/>
-            <a:ext cx="7315200" cy="365760"/>
+            <a:ext cx="10058400" cy="365760"/>
           </a:xfrm>
           <a:prstGeom prst="rect">
             <a:avLst/>
@@ -7998,7 +7998,7 @@
                   <a:srgbClr val="1A3A5C"/>
                 </a:solidFill>
               </a:rPr>
-              <a:t>Profil C_ADC1 sur 6 cycles Q3W :</a:t>
+              <a:t>Terme kill dans Fornari :  dCMP/dt  =  ...  -  Slope_CMP x Damage x CMP</a:t>
             </a:r>
           </a:p>
         </p:txBody>
@@ -8011,8 +8011,8 @@
         </p:nvSpPr>
         <p:spPr>
           <a:xfrm>
-            <a:off x="640080" y="1920240"/>
-            <a:ext cx="10515600" cy="1371600"/>
+            <a:off x="640080" y="1965960"/>
+            <a:ext cx="10332720" cy="1463040"/>
           </a:xfrm>
           <a:prstGeom prst="rect">
             <a:avLst/>
@@ -8032,9 +8032,10 @@
                   <a:srgbClr val="444444"/>
                 </a:solidFill>
               </a:rPr>
-              <a:t>  Cycle 1       Cycle 2       Cycle 3       Cycle 4       Cycle 5       Cycle 6
-   Cmax=127     ~~~~~~~~~~~~~~~~~~~~~~~~~~~~~~~~~~~~~~~~~~~~~~~~~~~~~~~~~~~~
-   --------    Trough ≈ 60 ug/mL (E_drug ≈ 68% IC50)    -&gt; jamais nulle</a:t>
+              <a:t>  -&gt; Kill_CMP = Slope_CMP x Damage   (terme LINEAIRE, pas de seuil)
+  -&gt; Si Damage &gt; 0, meme tres faible, il y a toujours une suppression de CMP
+  -&gt; Avec T½ ADC = 23j &gt; Q3W = 21j : C_ADC1 trough ≈ 60 ug/mL entre cycles
+  -&gt; Damage residuel ≠ 0  =&gt;  Kill ≠ 0  =&gt;  tous les patients ont Neut &lt; baseline</a:t>
             </a:r>
           </a:p>
         </p:txBody>
@@ -8047,7 +8048,7 @@
         </p:nvSpPr>
         <p:spPr>
           <a:xfrm>
-            <a:off x="457200" y="3657600"/>
+            <a:off x="457200" y="3749039"/>
             <a:ext cx="10972800" cy="411480"/>
           </a:xfrm>
           <a:prstGeom prst="rect">
@@ -8063,12 +8064,12 @@
           <a:p>
             <a:pPr algn="ctr"/>
             <a:r>
-              <a:rPr sz="1300" b="0" i="1">
-                <a:solidFill>
-                  <a:srgbClr val="B2182B"/>
-                </a:solidFill>
-              </a:rPr>
-              <a:t>=&gt; E_drug ne redescend jamais a 0 entre cycles =&gt; Damage residuel =&gt; tous les patients affectes</a:t>
+              <a:rPr sz="1200" b="0" i="1">
+                <a:solidFill>
+                  <a:srgbClr val="E67E00"/>
+                </a:solidFill>
+              </a:rPr>
+              <a:t>Le modele Fornari a ete concu pour le carboplatin (T½ court) : drug efface entre cycles -&gt; Damage = 0</a:t>
             </a:r>
           </a:p>
         </p:txBody>
@@ -8081,18 +8082,18 @@
         </p:nvSpPr>
         <p:spPr>
           <a:xfrm>
-            <a:off x="457200" y="4160520"/>
+            <a:off x="457200" y="4251960"/>
             <a:ext cx="5212080" cy="2286000"/>
           </a:xfrm>
           <a:prstGeom prst="rect">
             <a:avLst/>
           </a:prstGeom>
           <a:solidFill>
-            <a:srgbClr val="EBF7ED"/>
+            <a:srgbClr val="FEF0EB"/>
           </a:solidFill>
           <a:ln w="12700">
             <a:solidFill>
-              <a:srgbClr val="1A7A3C"/>
+              <a:srgbClr val="B2182B"/>
             </a:solidFill>
           </a:ln>
         </p:spPr>
@@ -8126,7 +8127,7 @@
         </p:nvSpPr>
         <p:spPr>
           <a:xfrm>
-            <a:off x="640080" y="4206240"/>
+            <a:off x="640080" y="4297680"/>
             <a:ext cx="4846320" cy="411480"/>
           </a:xfrm>
           <a:prstGeom prst="rect">
@@ -8144,10 +8145,10 @@
             <a:r>
               <a:rPr sz="1300" b="1" i="0">
                 <a:solidFill>
-                  <a:srgbClr val="1A7A3C"/>
-                </a:solidFill>
-              </a:rPr>
-              <a:t>Solutions explorees :</a:t>
+                  <a:srgbClr val="B2182B"/>
+                </a:solidFill>
+              </a:rPr>
+              <a:t>Pourquoi Fornari ne suffit pas ici :</a:t>
             </a:r>
           </a:p>
         </p:txBody>
@@ -8160,7 +8161,7 @@
         </p:nvSpPr>
         <p:spPr>
           <a:xfrm>
-            <a:off x="822960" y="4663440"/>
+            <a:off x="822960" y="4754880"/>
             <a:ext cx="4663440" cy="502920"/>
           </a:xfrm>
           <a:prstGeom prst="rect">
@@ -8181,8 +8182,8 @@
                   <a:srgbClr val="444444"/>
                 </a:solidFill>
               </a:rPr>
-              <a:t>n_hill=2 (Hill sigmoide) : attenue
-  E_drug sous IC50</a:t>
+              <a:t>Terme kill lineaire : pas de seuil en dessous
+  duquel l'effet est nul</a:t>
             </a:r>
           </a:p>
         </p:txBody>
@@ -8195,7 +8196,7 @@
         </p:nvSpPr>
         <p:spPr>
           <a:xfrm>
-            <a:off x="594360" y="4663440"/>
+            <a:off x="594360" y="4754880"/>
             <a:ext cx="274320" cy="365760"/>
           </a:xfrm>
           <a:prstGeom prst="rect">
@@ -8211,12 +8212,12 @@
           <a:p>
             <a:pPr algn="l"/>
             <a:r>
-              <a:rPr sz="1400" b="1" i="0">
-                <a:solidFill>
-                  <a:srgbClr val="1A7A3C"/>
-                </a:solidFill>
-              </a:rPr>
-              <a:t>-</a:t>
+              <a:rPr sz="1200" b="1" i="0">
+                <a:solidFill>
+                  <a:srgbClr val="B2182B"/>
+                </a:solidFill>
+              </a:rPr>
+              <a:t>x</a:t>
             </a:r>
           </a:p>
         </p:txBody>
@@ -8229,7 +8230,7 @@
         </p:nvSpPr>
         <p:spPr>
           <a:xfrm>
-            <a:off x="822960" y="5212079"/>
+            <a:off x="822960" y="5303520"/>
             <a:ext cx="4663440" cy="502920"/>
           </a:xfrm>
           <a:prstGeom prst="rect">
@@ -8250,8 +8251,8 @@
                   <a:srgbClr val="444444"/>
                 </a:solidFill>
               </a:rPr>
-              <a:t>Revenir a n_hill=1 + accepter la
-  limitation sur tout grade</a:t>
+              <a:t>Feedback (proliferation compensatrice) ne
+  compense pas un kill permanent</a:t>
             </a:r>
           </a:p>
         </p:txBody>
@@ -8264,7 +8265,7 @@
         </p:nvSpPr>
         <p:spPr>
           <a:xfrm>
-            <a:off x="594360" y="5212079"/>
+            <a:off x="594360" y="5303520"/>
             <a:ext cx="274320" cy="365760"/>
           </a:xfrm>
           <a:prstGeom prst="rect">
@@ -8280,12 +8281,12 @@
           <a:p>
             <a:pPr algn="l"/>
             <a:r>
-              <a:rPr sz="1400" b="1" i="0">
-                <a:solidFill>
-                  <a:srgbClr val="1A7A3C"/>
-                </a:solidFill>
-              </a:rPr>
-              <a:t>-</a:t>
+              <a:rPr sz="1200" b="1" i="0">
+                <a:solidFill>
+                  <a:srgbClr val="B2182B"/>
+                </a:solidFill>
+              </a:rPr>
+              <a:t>x</a:t>
             </a:r>
           </a:p>
         </p:txBody>
@@ -8298,7 +8299,7 @@
         </p:nvSpPr>
         <p:spPr>
           <a:xfrm>
-            <a:off x="822960" y="5760720"/>
+            <a:off x="822960" y="5852160"/>
             <a:ext cx="4663440" cy="502920"/>
           </a:xfrm>
           <a:prstGeom prst="rect">
@@ -8319,8 +8320,8 @@
                   <a:srgbClr val="444444"/>
                 </a:solidFill>
               </a:rPr>
-              <a:t>Reviser DXd PK (T½ court) pour
-  driver DXd_ic coherent</a:t>
+              <a:t>Concu pour agents a courte demi-vie,
+  pas pour ADC a longue T½</a:t>
             </a:r>
           </a:p>
         </p:txBody>
@@ -8333,7 +8334,7 @@
         </p:nvSpPr>
         <p:spPr>
           <a:xfrm>
-            <a:off x="594360" y="5760720"/>
+            <a:off x="594360" y="5852160"/>
             <a:ext cx="274320" cy="365760"/>
           </a:xfrm>
           <a:prstGeom prst="rect">
@@ -8349,12 +8350,12 @@
           <a:p>
             <a:pPr algn="l"/>
             <a:r>
-              <a:rPr sz="1400" b="1" i="0">
-                <a:solidFill>
-                  <a:srgbClr val="1A7A3C"/>
-                </a:solidFill>
-              </a:rPr>
-              <a:t>-</a:t>
+              <a:rPr sz="1200" b="1" i="0">
+                <a:solidFill>
+                  <a:srgbClr val="B2182B"/>
+                </a:solidFill>
+              </a:rPr>
+              <a:t>x</a:t>
             </a:r>
           </a:p>
         </p:txBody>
@@ -8367,7 +8368,7 @@
         </p:nvSpPr>
         <p:spPr>
           <a:xfrm>
-            <a:off x="6126480" y="4160520"/>
+            <a:off x="6126480" y="4251960"/>
             <a:ext cx="5394960" cy="2286000"/>
           </a:xfrm>
           <a:prstGeom prst="rect">
@@ -8412,7 +8413,7 @@
         </p:nvSpPr>
         <p:spPr>
           <a:xfrm>
-            <a:off x="6309360" y="4206240"/>
+            <a:off x="6309360" y="4297680"/>
             <a:ext cx="5029200" cy="411480"/>
           </a:xfrm>
           <a:prstGeom prst="rect">
@@ -8433,7 +8434,7 @@
                   <a:srgbClr val="E67E00"/>
                 </a:solidFill>
               </a:rPr>
-              <a:t>Choix actuel :</a:t>
+              <a:t>Ce qu'il faudrait :</a:t>
             </a:r>
           </a:p>
         </p:txBody>
@@ -8446,8 +8447,8 @@
         </p:nvSpPr>
         <p:spPr>
           <a:xfrm>
-            <a:off x="6309360" y="4617720"/>
-            <a:ext cx="5029200" cy="1737360"/>
+            <a:off x="6309360" y="4754880"/>
+            <a:ext cx="5029200" cy="502920"/>
           </a:xfrm>
           <a:prstGeom prst="rect">
             <a:avLst/>
@@ -8467,11 +8468,180 @@
                   <a:srgbClr val="444444"/>
                 </a:solidFill>
               </a:rPr>
-              <a:t>n_hill=1 + use_ADC_driver=TRUE
-Priorite : reproduire G3-4 correctement
-Tout grade non reproduit = limitation
-documentee (acceptable pour calibration
-dose-finding)</a:t>
+              <a:t>Modifier Fornari : ajouter un seuil
+  minimal de Damage effectif</a:t>
+            </a:r>
+          </a:p>
+        </p:txBody>
+      </p:sp>
+      <p:sp>
+        <p:nvSpPr>
+          <p:cNvPr id="20" name="TextBox 19"/>
+          <p:cNvSpPr txBox="1"/>
+          <p:nvPr/>
+        </p:nvSpPr>
+        <p:spPr>
+          <a:xfrm>
+            <a:off x="6126480" y="4754880"/>
+            <a:ext cx="228600" cy="365760"/>
+          </a:xfrm>
+          <a:prstGeom prst="rect">
+            <a:avLst/>
+          </a:prstGeom>
+          <a:noFill/>
+        </p:spPr>
+        <p:txBody>
+          <a:bodyPr wrap="square">
+            <a:spAutoFit/>
+          </a:bodyPr>
+          <a:lstStyle/>
+          <a:p>
+            <a:pPr algn="l"/>
+            <a:r>
+              <a:rPr sz="1100" b="1" i="0">
+                <a:solidFill>
+                  <a:srgbClr val="E67E00"/>
+                </a:solidFill>
+              </a:rPr>
+              <a:t>-&gt;</a:t>
+            </a:r>
+          </a:p>
+        </p:txBody>
+      </p:sp>
+      <p:sp>
+        <p:nvSpPr>
+          <p:cNvPr id="21" name="TextBox 20"/>
+          <p:cNvSpPr txBox="1"/>
+          <p:nvPr/>
+        </p:nvSpPr>
+        <p:spPr>
+          <a:xfrm>
+            <a:off x="6309360" y="5303520"/>
+            <a:ext cx="5029200" cy="502920"/>
+          </a:xfrm>
+          <a:prstGeom prst="rect">
+            <a:avLst/>
+          </a:prstGeom>
+          <a:noFill/>
+        </p:spPr>
+        <p:txBody>
+          <a:bodyPr wrap="square">
+            <a:spAutoFit/>
+          </a:bodyPr>
+          <a:lstStyle/>
+          <a:p>
+            <a:pPr algn="l"/>
+            <a:r>
+              <a:rPr sz="1100" b="0" i="0">
+                <a:solidFill>
+                  <a:srgbClr val="444444"/>
+                </a:solidFill>
+              </a:rPr>
+              <a:t>Ou adapter le kill term pour ADC
+  (dependance non-lineaire du Damage)</a:t>
+            </a:r>
+          </a:p>
+        </p:txBody>
+      </p:sp>
+      <p:sp>
+        <p:nvSpPr>
+          <p:cNvPr id="22" name="TextBox 21"/>
+          <p:cNvSpPr txBox="1"/>
+          <p:nvPr/>
+        </p:nvSpPr>
+        <p:spPr>
+          <a:xfrm>
+            <a:off x="6126480" y="5303520"/>
+            <a:ext cx="228600" cy="365760"/>
+          </a:xfrm>
+          <a:prstGeom prst="rect">
+            <a:avLst/>
+          </a:prstGeom>
+          <a:noFill/>
+        </p:spPr>
+        <p:txBody>
+          <a:bodyPr wrap="square">
+            <a:spAutoFit/>
+          </a:bodyPr>
+          <a:lstStyle/>
+          <a:p>
+            <a:pPr algn="l"/>
+            <a:r>
+              <a:rPr sz="1100" b="1" i="0">
+                <a:solidFill>
+                  <a:srgbClr val="E67E00"/>
+                </a:solidFill>
+              </a:rPr>
+              <a:t>-&gt;</a:t>
+            </a:r>
+          </a:p>
+        </p:txBody>
+      </p:sp>
+      <p:sp>
+        <p:nvSpPr>
+          <p:cNvPr id="23" name="TextBox 22"/>
+          <p:cNvSpPr txBox="1"/>
+          <p:nvPr/>
+        </p:nvSpPr>
+        <p:spPr>
+          <a:xfrm>
+            <a:off x="6309360" y="5852160"/>
+            <a:ext cx="5029200" cy="502920"/>
+          </a:xfrm>
+          <a:prstGeom prst="rect">
+            <a:avLst/>
+          </a:prstGeom>
+          <a:noFill/>
+        </p:spPr>
+        <p:txBody>
+          <a:bodyPr wrap="square">
+            <a:spAutoFit/>
+          </a:bodyPr>
+          <a:lstStyle/>
+          <a:p>
+            <a:pPr algn="l"/>
+            <a:r>
+              <a:rPr sz="1100" b="0" i="0">
+                <a:solidFill>
+                  <a:srgbClr val="444444"/>
+                </a:solidFill>
+              </a:rPr>
+              <a:t>Ou utiliser un modele PD different
+  pour les ADC a longue T½</a:t>
+            </a:r>
+          </a:p>
+        </p:txBody>
+      </p:sp>
+      <p:sp>
+        <p:nvSpPr>
+          <p:cNvPr id="24" name="TextBox 23"/>
+          <p:cNvSpPr txBox="1"/>
+          <p:nvPr/>
+        </p:nvSpPr>
+        <p:spPr>
+          <a:xfrm>
+            <a:off x="6126480" y="5852160"/>
+            <a:ext cx="228600" cy="365760"/>
+          </a:xfrm>
+          <a:prstGeom prst="rect">
+            <a:avLst/>
+          </a:prstGeom>
+          <a:noFill/>
+        </p:spPr>
+        <p:txBody>
+          <a:bodyPr wrap="square">
+            <a:spAutoFit/>
+          </a:bodyPr>
+          <a:lstStyle/>
+          <a:p>
+            <a:pPr algn="l"/>
+            <a:r>
+              <a:rPr sz="1100" b="1" i="0">
+                <a:solidFill>
+                  <a:srgbClr val="E67E00"/>
+                </a:solidFill>
+              </a:rPr>
+              <a:t>-&gt;</a:t>
             </a:r>
           </a:p>
         </p:txBody>
@@ -9213,7 +9383,7 @@
                   <a:srgbClr val="FFFFFF"/>
                 </a:solidFill>
               </a:rPr>
-              <a:t>3. Reproduire tout grade (Priorite moyenne)</a:t>
+              <a:t>3. Adapter le modele Fornari pour les ADC a longue T½ (Priorite moyenne)</a:t>
             </a:r>
           </a:p>
         </p:txBody>
@@ -9247,7 +9417,7 @@
                   <a:srgbClr val="444444"/>
                 </a:solidFill>
               </a:rPr>
-              <a:t>   Tester n_hill=2 avec DXd_ic driver (une fois PK corrigee)</a:t>
+              <a:t>   Fornari concu pour carboplatin (T½ court) : kill terme lineaire sans seuil</a:t>
             </a:r>
           </a:p>
         </p:txBody>
@@ -9315,7 +9485,7 @@
                   <a:srgbClr val="444444"/>
                 </a:solidFill>
               </a:rPr>
-              <a:t>   n_hill=2 reduit E_drug sub-IC50 -&gt; attenue nadir entre cycles</a:t>
+              <a:t>   Modifier le terme kill pour rendre l'effet nul en dessous d'un Damage seuil</a:t>
             </a:r>
           </a:p>
         </p:txBody>
@@ -9383,7 +9553,7 @@
                   <a:srgbClr val="444444"/>
                 </a:solidFill>
               </a:rPr>
-              <a:t>   Cible : tout grade ~29% (FDA DESTINY-Breast01)</a:t>
+              <a:t>   Objectif : tout grade ~29% (FDA) au lieu de 100% predit actuellement</a:t>
             </a:r>
           </a:p>
         </p:txBody>
@@ -10557,7 +10727,7 @@
                   <a:srgbClr val="FFDD77"/>
                 </a:solidFill>
               </a:rPr>
-              <a:t>Modele fonctionnel pour G3-4. Priorite : corriger T½ DXd pour driver mecanistique aligne FDA.</a:t>
+              <a:t>Modele fonctionnel pour G3-4. Priorite : corriger DXd PK + adapter Fornari pour ADC longue T½.</a:t>
             </a:r>
           </a:p>
         </p:txBody>

</xml_diff>

<commit_message>
Simplifier slide prochaines etapes (4 items, 1 ligne chacun)
https://claude.ai/code/session_01LRQofhjhvxSvgMrvYoaEon
</commit_message>
<xml_diff>
--- a/scripts_tdxd/results_PKPD_human/TDXd_PKPD_Bilan.pptx
+++ b/scripts_tdxd/results_PKPD_human/TDXd_PKPD_Bilan.pptx
@@ -8757,8 +8757,8 @@
         </p:nvSpPr>
         <p:spPr>
           <a:xfrm>
-            <a:off x="365760" y="960120"/>
-            <a:ext cx="11430000" cy="411480"/>
+            <a:off x="365760" y="1051560"/>
+            <a:ext cx="685800" cy="685800"/>
           </a:xfrm>
           <a:prstGeom prst="rect">
             <a:avLst/>
@@ -8800,8 +8800,42 @@
         </p:nvSpPr>
         <p:spPr>
           <a:xfrm>
-            <a:off x="502920" y="987552"/>
-            <a:ext cx="10972800" cy="365760"/>
+            <a:off x="365760" y="1124712"/>
+            <a:ext cx="685800" cy="548640"/>
+          </a:xfrm>
+          <a:prstGeom prst="rect">
+            <a:avLst/>
+          </a:prstGeom>
+          <a:noFill/>
+        </p:spPr>
+        <p:txBody>
+          <a:bodyPr wrap="square">
+            <a:spAutoFit/>
+          </a:bodyPr>
+          <a:lstStyle/>
+          <a:p>
+            <a:pPr algn="ctr"/>
+            <a:r>
+              <a:rPr sz="2200" b="1" i="0">
+                <a:solidFill>
+                  <a:srgbClr val="FFFFFF"/>
+                </a:solidFill>
+              </a:rPr>
+              <a:t>1</a:t>
+            </a:r>
+          </a:p>
+        </p:txBody>
+      </p:sp>
+      <p:sp>
+        <p:nvSpPr>
+          <p:cNvPr id="6" name="TextBox 5"/>
+          <p:cNvSpPr txBox="1"/>
+          <p:nvPr/>
+        </p:nvSpPr>
+        <p:spPr>
+          <a:xfrm>
+            <a:off x="1234440" y="1051560"/>
+            <a:ext cx="10058400" cy="384048"/>
           </a:xfrm>
           <a:prstGeom prst="rect">
             <a:avLst/>
@@ -8816,26 +8850,26 @@
           <a:p>
             <a:pPr algn="l"/>
             <a:r>
-              <a:rPr sz="1300" b="1" i="0">
-                <a:solidFill>
-                  <a:srgbClr val="FFFFFF"/>
-                </a:solidFill>
-              </a:rPr>
-              <a:t>1. Corriger le DXd PK (Priorite haute)</a:t>
-            </a:r>
-          </a:p>
-        </p:txBody>
-      </p:sp>
-      <p:sp>
-        <p:nvSpPr>
-          <p:cNvPr id="6" name="TextBox 5"/>
-          <p:cNvSpPr txBox="1"/>
-          <p:nvPr/>
-        </p:nvSpPr>
-        <p:spPr>
-          <a:xfrm>
-            <a:off x="731520" y="1399032"/>
-            <a:ext cx="10972800" cy="347472"/>
+              <a:rPr sz="1500" b="1" i="0">
+                <a:solidFill>
+                  <a:srgbClr val="B2182B"/>
+                </a:solidFill>
+              </a:rPr>
+              <a:t>Corriger le PK du DXd</a:t>
+            </a:r>
+          </a:p>
+        </p:txBody>
+      </p:sp>
+      <p:sp>
+        <p:nvSpPr>
+          <p:cNvPr id="7" name="TextBox 6"/>
+          <p:cNvSpPr txBox="1"/>
+          <p:nvPr/>
+        </p:nvSpPr>
+        <p:spPr>
+          <a:xfrm>
+            <a:off x="1234440" y="1463039"/>
+            <a:ext cx="10058400" cy="411480"/>
           </a:xfrm>
           <a:prstGeom prst="rect">
             <a:avLst/>
@@ -8850,264 +8884,26 @@
           <a:p>
             <a:pPr algn="l"/>
             <a:r>
-              <a:rPr sz="1100" b="0" i="0">
+              <a:rPr sz="1200" b="0" i="0">
                 <a:solidFill>
                   <a:srgbClr val="444444"/>
                 </a:solidFill>
               </a:rPr>
-              <a:t>   T½ DXd modele = 1.06h   vs   FDA apparent = 5.8j</a:t>
-            </a:r>
-          </a:p>
-        </p:txBody>
-      </p:sp>
-      <p:sp>
-        <p:nvSpPr>
-          <p:cNvPr id="7" name="TextBox 6"/>
-          <p:cNvSpPr txBox="1"/>
-          <p:nvPr/>
-        </p:nvSpPr>
-        <p:spPr>
-          <a:xfrm>
-            <a:off x="502920" y="1399032"/>
-            <a:ext cx="274320" cy="320040"/>
-          </a:xfrm>
-          <a:prstGeom prst="rect">
-            <a:avLst/>
-          </a:prstGeom>
-          <a:noFill/>
-        </p:spPr>
-        <p:txBody>
-          <a:bodyPr wrap="square">
-            <a:spAutoFit/>
-          </a:bodyPr>
-          <a:lstStyle/>
-          <a:p>
-            <a:pPr algn="l"/>
-            <a:r>
-              <a:rPr sz="1100" b="0" i="0">
-                <a:solidFill>
-                  <a:srgbClr val="B2182B"/>
-                </a:solidFill>
-              </a:rPr>
-              <a:t>-&gt;</a:t>
-            </a:r>
-          </a:p>
-        </p:txBody>
-      </p:sp>
-      <p:sp>
-        <p:nvSpPr>
-          <p:cNvPr id="8" name="TextBox 7"/>
-          <p:cNvSpPr txBox="1"/>
-          <p:nvPr/>
-        </p:nvSpPr>
-        <p:spPr>
-          <a:xfrm>
-            <a:off x="731520" y="1737360"/>
-            <a:ext cx="10972800" cy="347472"/>
-          </a:xfrm>
-          <a:prstGeom prst="rect">
-            <a:avLst/>
-          </a:prstGeom>
-          <a:noFill/>
-        </p:spPr>
-        <p:txBody>
-          <a:bodyPr wrap="square">
-            <a:spAutoFit/>
-          </a:bodyPr>
-          <a:lstStyle/>
-          <a:p>
-            <a:pPr algn="l"/>
-            <a:r>
-              <a:rPr sz="1100" b="0" i="0">
-                <a:solidFill>
-                  <a:srgbClr val="444444"/>
-                </a:solidFill>
-              </a:rPr>
-              <a:t>   Ajouter un 2e compartiment DXd (lié/libre) ou ralentir k_effD</a:t>
-            </a:r>
-          </a:p>
-        </p:txBody>
-      </p:sp>
-      <p:sp>
-        <p:nvSpPr>
-          <p:cNvPr id="9" name="TextBox 8"/>
-          <p:cNvSpPr txBox="1"/>
-          <p:nvPr/>
-        </p:nvSpPr>
-        <p:spPr>
-          <a:xfrm>
-            <a:off x="502920" y="1737360"/>
-            <a:ext cx="274320" cy="320040"/>
-          </a:xfrm>
-          <a:prstGeom prst="rect">
-            <a:avLst/>
-          </a:prstGeom>
-          <a:noFill/>
-        </p:spPr>
-        <p:txBody>
-          <a:bodyPr wrap="square">
-            <a:spAutoFit/>
-          </a:bodyPr>
-          <a:lstStyle/>
-          <a:p>
-            <a:pPr algn="l"/>
-            <a:r>
-              <a:rPr sz="1100" b="0" i="0">
-                <a:solidFill>
-                  <a:srgbClr val="B2182B"/>
-                </a:solidFill>
-              </a:rPr>
-              <a:t>-&gt;</a:t>
-            </a:r>
-          </a:p>
-        </p:txBody>
-      </p:sp>
-      <p:sp>
-        <p:nvSpPr>
-          <p:cNvPr id="10" name="TextBox 9"/>
-          <p:cNvSpPr txBox="1"/>
-          <p:nvPr/>
-        </p:nvSpPr>
-        <p:spPr>
-          <a:xfrm>
-            <a:off x="731520" y="2075688"/>
-            <a:ext cx="10972800" cy="347472"/>
-          </a:xfrm>
-          <a:prstGeom prst="rect">
-            <a:avLst/>
-          </a:prstGeom>
-          <a:noFill/>
-        </p:spPr>
-        <p:txBody>
-          <a:bodyPr wrap="square">
-            <a:spAutoFit/>
-          </a:bodyPr>
-          <a:lstStyle/>
-          <a:p>
-            <a:pPr algn="l"/>
-            <a:r>
-              <a:rPr sz="1100" b="0" i="0">
-                <a:solidFill>
-                  <a:srgbClr val="444444"/>
-                </a:solidFill>
-              </a:rPr>
-              <a:t>   Objectif : DXd_ic Cavg suffisant pour driver toxicite</a:t>
-            </a:r>
-          </a:p>
-        </p:txBody>
-      </p:sp>
-      <p:sp>
-        <p:nvSpPr>
-          <p:cNvPr id="11" name="TextBox 10"/>
-          <p:cNvSpPr txBox="1"/>
-          <p:nvPr/>
-        </p:nvSpPr>
-        <p:spPr>
-          <a:xfrm>
-            <a:off x="502920" y="2075688"/>
-            <a:ext cx="274320" cy="320040"/>
-          </a:xfrm>
-          <a:prstGeom prst="rect">
-            <a:avLst/>
-          </a:prstGeom>
-          <a:noFill/>
-        </p:spPr>
-        <p:txBody>
-          <a:bodyPr wrap="square">
-            <a:spAutoFit/>
-          </a:bodyPr>
-          <a:lstStyle/>
-          <a:p>
-            <a:pPr algn="l"/>
-            <a:r>
-              <a:rPr sz="1100" b="0" i="0">
-                <a:solidFill>
-                  <a:srgbClr val="B2182B"/>
-                </a:solidFill>
-              </a:rPr>
-              <a:t>-&gt;</a:t>
-            </a:r>
-          </a:p>
-        </p:txBody>
-      </p:sp>
-      <p:sp>
-        <p:nvSpPr>
-          <p:cNvPr id="12" name="TextBox 11"/>
-          <p:cNvSpPr txBox="1"/>
-          <p:nvPr/>
-        </p:nvSpPr>
-        <p:spPr>
-          <a:xfrm>
-            <a:off x="731520" y="2414016"/>
-            <a:ext cx="10972800" cy="347472"/>
-          </a:xfrm>
-          <a:prstGeom prst="rect">
-            <a:avLst/>
-          </a:prstGeom>
-          <a:noFill/>
-        </p:spPr>
-        <p:txBody>
-          <a:bodyPr wrap="square">
-            <a:spAutoFit/>
-          </a:bodyPr>
-          <a:lstStyle/>
-          <a:p>
-            <a:pPr algn="l"/>
-            <a:r>
-              <a:rPr sz="1100" b="0" i="0">
-                <a:solidFill>
-                  <a:srgbClr val="444444"/>
-                </a:solidFill>
-              </a:rPr>
-              <a:t>   -&gt; Permettra d'utiliser C_DXd_ic comme driver (aligne FDA p.95)</a:t>
-            </a:r>
-          </a:p>
-        </p:txBody>
-      </p:sp>
-      <p:sp>
-        <p:nvSpPr>
-          <p:cNvPr id="13" name="TextBox 12"/>
-          <p:cNvSpPr txBox="1"/>
-          <p:nvPr/>
-        </p:nvSpPr>
-        <p:spPr>
-          <a:xfrm>
-            <a:off x="502920" y="2414016"/>
-            <a:ext cx="274320" cy="320040"/>
-          </a:xfrm>
-          <a:prstGeom prst="rect">
-            <a:avLst/>
-          </a:prstGeom>
-          <a:noFill/>
-        </p:spPr>
-        <p:txBody>
-          <a:bodyPr wrap="square">
-            <a:spAutoFit/>
-          </a:bodyPr>
-          <a:lstStyle/>
-          <a:p>
-            <a:pPr algn="l"/>
-            <a:r>
-              <a:rPr sz="1100" b="0" i="0">
-                <a:solidFill>
-                  <a:srgbClr val="B2182B"/>
-                </a:solidFill>
-              </a:rPr>
-              <a:t>-&gt;</a:t>
-            </a:r>
-          </a:p>
-        </p:txBody>
-      </p:sp>
-      <p:sp>
-        <p:nvSpPr>
-          <p:cNvPr id="14" name="Rectangle 13"/>
+              <a:t>T½ modele = 1h vs FDA = 5.8j  -&gt;  ajouter compartiment DXd lie/libre</a:t>
+            </a:r>
+          </a:p>
+        </p:txBody>
+      </p:sp>
+      <p:sp>
+        <p:nvSpPr>
+          <p:cNvPr id="8" name="Rectangle 7"/>
           <p:cNvSpPr/>
           <p:nvPr/>
         </p:nvSpPr>
         <p:spPr>
           <a:xfrm>
-            <a:off x="365760" y="2843784"/>
-            <a:ext cx="11430000" cy="411480"/>
+            <a:off x="365760" y="2377439"/>
+            <a:ext cx="685800" cy="685800"/>
           </a:xfrm>
           <a:prstGeom prst="rect">
             <a:avLst/>
@@ -9143,14 +8939,48 @@
       </p:sp>
       <p:sp>
         <p:nvSpPr>
-          <p:cNvPr id="15" name="TextBox 14"/>
-          <p:cNvSpPr txBox="1"/>
-          <p:nvPr/>
-        </p:nvSpPr>
-        <p:spPr>
-          <a:xfrm>
-            <a:off x="502920" y="2871216"/>
-            <a:ext cx="10972800" cy="365760"/>
+          <p:cNvPr id="9" name="TextBox 8"/>
+          <p:cNvSpPr txBox="1"/>
+          <p:nvPr/>
+        </p:nvSpPr>
+        <p:spPr>
+          <a:xfrm>
+            <a:off x="365760" y="2450591"/>
+            <a:ext cx="685800" cy="548640"/>
+          </a:xfrm>
+          <a:prstGeom prst="rect">
+            <a:avLst/>
+          </a:prstGeom>
+          <a:noFill/>
+        </p:spPr>
+        <p:txBody>
+          <a:bodyPr wrap="square">
+            <a:spAutoFit/>
+          </a:bodyPr>
+          <a:lstStyle/>
+          <a:p>
+            <a:pPr algn="ctr"/>
+            <a:r>
+              <a:rPr sz="2200" b="1" i="0">
+                <a:solidFill>
+                  <a:srgbClr val="FFFFFF"/>
+                </a:solidFill>
+              </a:rPr>
+              <a:t>2</a:t>
+            </a:r>
+          </a:p>
+        </p:txBody>
+      </p:sp>
+      <p:sp>
+        <p:nvSpPr>
+          <p:cNvPr id="10" name="TextBox 9"/>
+          <p:cNvSpPr txBox="1"/>
+          <p:nvPr/>
+        </p:nvSpPr>
+        <p:spPr>
+          <a:xfrm>
+            <a:off x="1234440" y="2377439"/>
+            <a:ext cx="10058400" cy="384048"/>
           </a:xfrm>
           <a:prstGeom prst="rect">
             <a:avLst/>
@@ -9165,26 +8995,26 @@
           <a:p>
             <a:pPr algn="l"/>
             <a:r>
-              <a:rPr sz="1300" b="1" i="0">
-                <a:solidFill>
-                  <a:srgbClr val="FFFFFF"/>
-                </a:solidFill>
-              </a:rPr>
-              <a:t>2. Recalibrer Slope_CMP apres correction PK (Priorite haute)</a:t>
-            </a:r>
-          </a:p>
-        </p:txBody>
-      </p:sp>
-      <p:sp>
-        <p:nvSpPr>
-          <p:cNvPr id="16" name="TextBox 15"/>
-          <p:cNvSpPr txBox="1"/>
-          <p:nvPr/>
-        </p:nvSpPr>
-        <p:spPr>
-          <a:xfrm>
-            <a:off x="731520" y="3282696"/>
-            <a:ext cx="10972800" cy="347472"/>
+              <a:rPr sz="1500" b="1" i="0">
+                <a:solidFill>
+                  <a:srgbClr val="B2182B"/>
+                </a:solidFill>
+              </a:rPr>
+              <a:t>Recalibrer Slope_CMP</a:t>
+            </a:r>
+          </a:p>
+        </p:txBody>
+      </p:sp>
+      <p:sp>
+        <p:nvSpPr>
+          <p:cNvPr id="11" name="TextBox 10"/>
+          <p:cNvSpPr txBox="1"/>
+          <p:nvPr/>
+        </p:nvSpPr>
+        <p:spPr>
+          <a:xfrm>
+            <a:off x="1234440" y="2788920"/>
+            <a:ext cx="10058400" cy="411480"/>
           </a:xfrm>
           <a:prstGeom prst="rect">
             <a:avLst/>
@@ -9199,128 +9029,26 @@
           <a:p>
             <a:pPr algn="l"/>
             <a:r>
-              <a:rPr sz="1100" b="0" i="0">
+              <a:rPr sz="1200" b="0" i="0">
                 <a:solidFill>
                   <a:srgbClr val="444444"/>
                 </a:solidFill>
               </a:rPr>
-              <a:t>   Quand DXd_ic Cavg sera realiste -&gt; re-scanner Slope_CMP</a:t>
-            </a:r>
-          </a:p>
-        </p:txBody>
-      </p:sp>
-      <p:sp>
-        <p:nvSpPr>
-          <p:cNvPr id="17" name="TextBox 16"/>
-          <p:cNvSpPr txBox="1"/>
-          <p:nvPr/>
-        </p:nvSpPr>
-        <p:spPr>
-          <a:xfrm>
-            <a:off x="502920" y="3282696"/>
-            <a:ext cx="274320" cy="320040"/>
-          </a:xfrm>
-          <a:prstGeom prst="rect">
-            <a:avLst/>
-          </a:prstGeom>
-          <a:noFill/>
-        </p:spPr>
-        <p:txBody>
-          <a:bodyPr wrap="square">
-            <a:spAutoFit/>
-          </a:bodyPr>
-          <a:lstStyle/>
-          <a:p>
-            <a:pPr algn="l"/>
-            <a:r>
-              <a:rPr sz="1100" b="0" i="0">
-                <a:solidFill>
-                  <a:srgbClr val="B2182B"/>
-                </a:solidFill>
-              </a:rPr>
-              <a:t>-&gt;</a:t>
-            </a:r>
-          </a:p>
-        </p:txBody>
-      </p:sp>
-      <p:sp>
-        <p:nvSpPr>
-          <p:cNvPr id="18" name="TextBox 17"/>
-          <p:cNvSpPr txBox="1"/>
-          <p:nvPr/>
-        </p:nvSpPr>
-        <p:spPr>
-          <a:xfrm>
-            <a:off x="731520" y="3621024"/>
-            <a:ext cx="10972800" cy="347472"/>
-          </a:xfrm>
-          <a:prstGeom prst="rect">
-            <a:avLst/>
-          </a:prstGeom>
-          <a:noFill/>
-        </p:spPr>
-        <p:txBody>
-          <a:bodyPr wrap="square">
-            <a:spAutoFit/>
-          </a:bodyPr>
-          <a:lstStyle/>
-          <a:p>
-            <a:pPr algn="l"/>
-            <a:r>
-              <a:rPr sz="1100" b="0" i="0">
-                <a:solidFill>
-                  <a:srgbClr val="444444"/>
-                </a:solidFill>
-              </a:rPr>
-              <a:t>   Cible inchangee : G3-4 neutropenie = 16-20%</a:t>
-            </a:r>
-          </a:p>
-        </p:txBody>
-      </p:sp>
-      <p:sp>
-        <p:nvSpPr>
-          <p:cNvPr id="19" name="TextBox 18"/>
-          <p:cNvSpPr txBox="1"/>
-          <p:nvPr/>
-        </p:nvSpPr>
-        <p:spPr>
-          <a:xfrm>
-            <a:off x="502920" y="3621024"/>
-            <a:ext cx="274320" cy="320040"/>
-          </a:xfrm>
-          <a:prstGeom prst="rect">
-            <a:avLst/>
-          </a:prstGeom>
-          <a:noFill/>
-        </p:spPr>
-        <p:txBody>
-          <a:bodyPr wrap="square">
-            <a:spAutoFit/>
-          </a:bodyPr>
-          <a:lstStyle/>
-          <a:p>
-            <a:pPr algn="l"/>
-            <a:r>
-              <a:rPr sz="1100" b="0" i="0">
-                <a:solidFill>
-                  <a:srgbClr val="B2182B"/>
-                </a:solidFill>
-              </a:rPr>
-              <a:t>-&gt;</a:t>
-            </a:r>
-          </a:p>
-        </p:txBody>
-      </p:sp>
-      <p:sp>
-        <p:nvSpPr>
-          <p:cNvPr id="20" name="Rectangle 19"/>
+              <a:t>Apres correction PK, re-scanner pour maintenir G3-4 neutropenie = 16-20%</a:t>
+            </a:r>
+          </a:p>
+        </p:txBody>
+      </p:sp>
+      <p:sp>
+        <p:nvSpPr>
+          <p:cNvPr id="12" name="Rectangle 11"/>
           <p:cNvSpPr/>
           <p:nvPr/>
         </p:nvSpPr>
         <p:spPr>
           <a:xfrm>
-            <a:off x="365760" y="4050791"/>
-            <a:ext cx="11430000" cy="411480"/>
+            <a:off x="365760" y="3703320"/>
+            <a:ext cx="685800" cy="685800"/>
           </a:xfrm>
           <a:prstGeom prst="rect">
             <a:avLst/>
@@ -9356,14 +9084,48 @@
       </p:sp>
       <p:sp>
         <p:nvSpPr>
-          <p:cNvPr id="21" name="TextBox 20"/>
-          <p:cNvSpPr txBox="1"/>
-          <p:nvPr/>
-        </p:nvSpPr>
-        <p:spPr>
-          <a:xfrm>
-            <a:off x="502920" y="4078224"/>
-            <a:ext cx="10972800" cy="365760"/>
+          <p:cNvPr id="13" name="TextBox 12"/>
+          <p:cNvSpPr txBox="1"/>
+          <p:nvPr/>
+        </p:nvSpPr>
+        <p:spPr>
+          <a:xfrm>
+            <a:off x="365760" y="3776472"/>
+            <a:ext cx="685800" cy="548640"/>
+          </a:xfrm>
+          <a:prstGeom prst="rect">
+            <a:avLst/>
+          </a:prstGeom>
+          <a:noFill/>
+        </p:spPr>
+        <p:txBody>
+          <a:bodyPr wrap="square">
+            <a:spAutoFit/>
+          </a:bodyPr>
+          <a:lstStyle/>
+          <a:p>
+            <a:pPr algn="ctr"/>
+            <a:r>
+              <a:rPr sz="2200" b="1" i="0">
+                <a:solidFill>
+                  <a:srgbClr val="FFFFFF"/>
+                </a:solidFill>
+              </a:rPr>
+              <a:t>3</a:t>
+            </a:r>
+          </a:p>
+        </p:txBody>
+      </p:sp>
+      <p:sp>
+        <p:nvSpPr>
+          <p:cNvPr id="14" name="TextBox 13"/>
+          <p:cNvSpPr txBox="1"/>
+          <p:nvPr/>
+        </p:nvSpPr>
+        <p:spPr>
+          <a:xfrm>
+            <a:off x="1234440" y="3703320"/>
+            <a:ext cx="10058400" cy="384048"/>
           </a:xfrm>
           <a:prstGeom prst="rect">
             <a:avLst/>
@@ -9378,26 +9140,26 @@
           <a:p>
             <a:pPr algn="l"/>
             <a:r>
-              <a:rPr sz="1300" b="1" i="0">
-                <a:solidFill>
-                  <a:srgbClr val="FFFFFF"/>
-                </a:solidFill>
-              </a:rPr>
-              <a:t>3. Adapter le modele Fornari pour les ADC a longue T½ (Priorite moyenne)</a:t>
-            </a:r>
-          </a:p>
-        </p:txBody>
-      </p:sp>
-      <p:sp>
-        <p:nvSpPr>
-          <p:cNvPr id="22" name="TextBox 21"/>
-          <p:cNvSpPr txBox="1"/>
-          <p:nvPr/>
-        </p:nvSpPr>
-        <p:spPr>
-          <a:xfrm>
-            <a:off x="731520" y="4489704"/>
-            <a:ext cx="10972800" cy="347472"/>
+              <a:rPr sz="1500" b="1" i="0">
+                <a:solidFill>
+                  <a:srgbClr val="E67E00"/>
+                </a:solidFill>
+              </a:rPr>
+              <a:t>Adapter le modele Fornari</a:t>
+            </a:r>
+          </a:p>
+        </p:txBody>
+      </p:sp>
+      <p:sp>
+        <p:nvSpPr>
+          <p:cNvPr id="15" name="TextBox 14"/>
+          <p:cNvSpPr txBox="1"/>
+          <p:nvPr/>
+        </p:nvSpPr>
+        <p:spPr>
+          <a:xfrm>
+            <a:off x="1234440" y="4114800"/>
+            <a:ext cx="10058400" cy="411480"/>
           </a:xfrm>
           <a:prstGeom prst="rect">
             <a:avLst/>
@@ -9412,196 +9174,26 @@
           <a:p>
             <a:pPr algn="l"/>
             <a:r>
-              <a:rPr sz="1100" b="0" i="0">
+              <a:rPr sz="1200" b="0" i="0">
                 <a:solidFill>
                   <a:srgbClr val="444444"/>
                 </a:solidFill>
               </a:rPr>
-              <a:t>   Fornari concu pour carboplatin (T½ court) : kill terme lineaire sans seuil</a:t>
-            </a:r>
-          </a:p>
-        </p:txBody>
-      </p:sp>
-      <p:sp>
-        <p:nvSpPr>
-          <p:cNvPr id="23" name="TextBox 22"/>
-          <p:cNvSpPr txBox="1"/>
-          <p:nvPr/>
-        </p:nvSpPr>
-        <p:spPr>
-          <a:xfrm>
-            <a:off x="502920" y="4489704"/>
-            <a:ext cx="274320" cy="320040"/>
-          </a:xfrm>
-          <a:prstGeom prst="rect">
-            <a:avLst/>
-          </a:prstGeom>
-          <a:noFill/>
-        </p:spPr>
-        <p:txBody>
-          <a:bodyPr wrap="square">
-            <a:spAutoFit/>
-          </a:bodyPr>
-          <a:lstStyle/>
-          <a:p>
-            <a:pPr algn="l"/>
-            <a:r>
-              <a:rPr sz="1100" b="0" i="0">
-                <a:solidFill>
-                  <a:srgbClr val="E67E00"/>
-                </a:solidFill>
-              </a:rPr>
-              <a:t>-&gt;</a:t>
-            </a:r>
-          </a:p>
-        </p:txBody>
-      </p:sp>
-      <p:sp>
-        <p:nvSpPr>
-          <p:cNvPr id="24" name="TextBox 23"/>
-          <p:cNvSpPr txBox="1"/>
-          <p:nvPr/>
-        </p:nvSpPr>
-        <p:spPr>
-          <a:xfrm>
-            <a:off x="731520" y="4828032"/>
-            <a:ext cx="10972800" cy="347472"/>
-          </a:xfrm>
-          <a:prstGeom prst="rect">
-            <a:avLst/>
-          </a:prstGeom>
-          <a:noFill/>
-        </p:spPr>
-        <p:txBody>
-          <a:bodyPr wrap="square">
-            <a:spAutoFit/>
-          </a:bodyPr>
-          <a:lstStyle/>
-          <a:p>
-            <a:pPr algn="l"/>
-            <a:r>
-              <a:rPr sz="1100" b="0" i="0">
-                <a:solidFill>
-                  <a:srgbClr val="444444"/>
-                </a:solidFill>
-              </a:rPr>
-              <a:t>   Modifier le terme kill pour rendre l'effet nul en dessous d'un Damage seuil</a:t>
-            </a:r>
-          </a:p>
-        </p:txBody>
-      </p:sp>
-      <p:sp>
-        <p:nvSpPr>
-          <p:cNvPr id="25" name="TextBox 24"/>
-          <p:cNvSpPr txBox="1"/>
-          <p:nvPr/>
-        </p:nvSpPr>
-        <p:spPr>
-          <a:xfrm>
-            <a:off x="502920" y="4828032"/>
-            <a:ext cx="274320" cy="320040"/>
-          </a:xfrm>
-          <a:prstGeom prst="rect">
-            <a:avLst/>
-          </a:prstGeom>
-          <a:noFill/>
-        </p:spPr>
-        <p:txBody>
-          <a:bodyPr wrap="square">
-            <a:spAutoFit/>
-          </a:bodyPr>
-          <a:lstStyle/>
-          <a:p>
-            <a:pPr algn="l"/>
-            <a:r>
-              <a:rPr sz="1100" b="0" i="0">
-                <a:solidFill>
-                  <a:srgbClr val="E67E00"/>
-                </a:solidFill>
-              </a:rPr>
-              <a:t>-&gt;</a:t>
-            </a:r>
-          </a:p>
-        </p:txBody>
-      </p:sp>
-      <p:sp>
-        <p:nvSpPr>
-          <p:cNvPr id="26" name="TextBox 25"/>
-          <p:cNvSpPr txBox="1"/>
-          <p:nvPr/>
-        </p:nvSpPr>
-        <p:spPr>
-          <a:xfrm>
-            <a:off x="731520" y="5166360"/>
-            <a:ext cx="10972800" cy="347472"/>
-          </a:xfrm>
-          <a:prstGeom prst="rect">
-            <a:avLst/>
-          </a:prstGeom>
-          <a:noFill/>
-        </p:spPr>
-        <p:txBody>
-          <a:bodyPr wrap="square">
-            <a:spAutoFit/>
-          </a:bodyPr>
-          <a:lstStyle/>
-          <a:p>
-            <a:pPr algn="l"/>
-            <a:r>
-              <a:rPr sz="1100" b="0" i="0">
-                <a:solidFill>
-                  <a:srgbClr val="444444"/>
-                </a:solidFill>
-              </a:rPr>
-              <a:t>   Objectif : tout grade ~29% (FDA) au lieu de 100% predit actuellement</a:t>
-            </a:r>
-          </a:p>
-        </p:txBody>
-      </p:sp>
-      <p:sp>
-        <p:nvSpPr>
-          <p:cNvPr id="27" name="TextBox 26"/>
-          <p:cNvSpPr txBox="1"/>
-          <p:nvPr/>
-        </p:nvSpPr>
-        <p:spPr>
-          <a:xfrm>
-            <a:off x="502920" y="5166360"/>
-            <a:ext cx="274320" cy="320040"/>
-          </a:xfrm>
-          <a:prstGeom prst="rect">
-            <a:avLst/>
-          </a:prstGeom>
-          <a:noFill/>
-        </p:spPr>
-        <p:txBody>
-          <a:bodyPr wrap="square">
-            <a:spAutoFit/>
-          </a:bodyPr>
-          <a:lstStyle/>
-          <a:p>
-            <a:pPr algn="l"/>
-            <a:r>
-              <a:rPr sz="1100" b="0" i="0">
-                <a:solidFill>
-                  <a:srgbClr val="E67E00"/>
-                </a:solidFill>
-              </a:rPr>
-              <a:t>-&gt;</a:t>
-            </a:r>
-          </a:p>
-        </p:txBody>
-      </p:sp>
-      <p:sp>
-        <p:nvSpPr>
-          <p:cNvPr id="28" name="Rectangle 27"/>
+              <a:t>Terme kill lineaire inadapte aux ADC longue T½  -&gt;  ajouter seuil Damage</a:t>
+            </a:r>
+          </a:p>
+        </p:txBody>
+      </p:sp>
+      <p:sp>
+        <p:nvSpPr>
+          <p:cNvPr id="16" name="Rectangle 15"/>
           <p:cNvSpPr/>
           <p:nvPr/>
         </p:nvSpPr>
         <p:spPr>
           <a:xfrm>
-            <a:off x="365760" y="5596128"/>
-            <a:ext cx="11430000" cy="411480"/>
+            <a:off x="365760" y="5029200"/>
+            <a:ext cx="685800" cy="685800"/>
           </a:xfrm>
           <a:prstGeom prst="rect">
             <a:avLst/>
@@ -9637,14 +9229,48 @@
       </p:sp>
       <p:sp>
         <p:nvSpPr>
-          <p:cNvPr id="29" name="TextBox 28"/>
-          <p:cNvSpPr txBox="1"/>
-          <p:nvPr/>
-        </p:nvSpPr>
-        <p:spPr>
-          <a:xfrm>
-            <a:off x="502920" y="5623560"/>
-            <a:ext cx="10972800" cy="365760"/>
+          <p:cNvPr id="17" name="TextBox 16"/>
+          <p:cNvSpPr txBox="1"/>
+          <p:nvPr/>
+        </p:nvSpPr>
+        <p:spPr>
+          <a:xfrm>
+            <a:off x="365760" y="5102352"/>
+            <a:ext cx="685800" cy="548640"/>
+          </a:xfrm>
+          <a:prstGeom prst="rect">
+            <a:avLst/>
+          </a:prstGeom>
+          <a:noFill/>
+        </p:spPr>
+        <p:txBody>
+          <a:bodyPr wrap="square">
+            <a:spAutoFit/>
+          </a:bodyPr>
+          <a:lstStyle/>
+          <a:p>
+            <a:pPr algn="ctr"/>
+            <a:r>
+              <a:rPr sz="2200" b="1" i="0">
+                <a:solidFill>
+                  <a:srgbClr val="FFFFFF"/>
+                </a:solidFill>
+              </a:rPr>
+              <a:t>4</a:t>
+            </a:r>
+          </a:p>
+        </p:txBody>
+      </p:sp>
+      <p:sp>
+        <p:nvSpPr>
+          <p:cNvPr id="18" name="TextBox 17"/>
+          <p:cNvSpPr txBox="1"/>
+          <p:nvPr/>
+        </p:nvSpPr>
+        <p:spPr>
+          <a:xfrm>
+            <a:off x="1234440" y="5029200"/>
+            <a:ext cx="10058400" cy="384048"/>
           </a:xfrm>
           <a:prstGeom prst="rect">
             <a:avLst/>
@@ -9659,26 +9285,26 @@
           <a:p>
             <a:pPr algn="l"/>
             <a:r>
-              <a:rPr sz="1300" b="1" i="0">
-                <a:solidFill>
-                  <a:srgbClr val="FFFFFF"/>
-                </a:solidFill>
-              </a:rPr>
-              <a:t>4. Valider PD rat (Priorite basse)</a:t>
-            </a:r>
-          </a:p>
-        </p:txBody>
-      </p:sp>
-      <p:sp>
-        <p:nvSpPr>
-          <p:cNvPr id="30" name="TextBox 29"/>
-          <p:cNvSpPr txBox="1"/>
-          <p:nvPr/>
-        </p:nvSpPr>
-        <p:spPr>
-          <a:xfrm>
-            <a:off x="731520" y="6035040"/>
-            <a:ext cx="10972800" cy="347472"/>
+              <a:rPr sz="1500" b="1" i="0">
+                <a:solidFill>
+                  <a:srgbClr val="2166AC"/>
+                </a:solidFill>
+              </a:rPr>
+              <a:t>Valider PD rat</a:t>
+            </a:r>
+          </a:p>
+        </p:txBody>
+      </p:sp>
+      <p:sp>
+        <p:nvSpPr>
+          <p:cNvPr id="19" name="TextBox 18"/>
+          <p:cNvSpPr txBox="1"/>
+          <p:nvPr/>
+        </p:nvSpPr>
+        <p:spPr>
+          <a:xfrm>
+            <a:off x="1234440" y="5440680"/>
+            <a:ext cx="10058400" cy="411480"/>
           </a:xfrm>
           <a:prstGeom prst="rect">
             <a:avLst/>
@@ -9693,114 +9319,12 @@
           <a:p>
             <a:pPr algn="l"/>
             <a:r>
-              <a:rPr sz="1100" b="0" i="0">
+              <a:rPr sz="1200" b="0" i="0">
                 <a:solidFill>
                   <a:srgbClr val="444444"/>
                 </a:solidFill>
               </a:rPr>
-              <a:t>   Aucune donnee experimentale rat utilisee pour PD (nadir Neut/Plt)</a:t>
-            </a:r>
-          </a:p>
-        </p:txBody>
-      </p:sp>
-      <p:sp>
-        <p:nvSpPr>
-          <p:cNvPr id="31" name="TextBox 30"/>
-          <p:cNvSpPr txBox="1"/>
-          <p:nvPr/>
-        </p:nvSpPr>
-        <p:spPr>
-          <a:xfrm>
-            <a:off x="502920" y="6035040"/>
-            <a:ext cx="274320" cy="320040"/>
-          </a:xfrm>
-          <a:prstGeom prst="rect">
-            <a:avLst/>
-          </a:prstGeom>
-          <a:noFill/>
-        </p:spPr>
-        <p:txBody>
-          <a:bodyPr wrap="square">
-            <a:spAutoFit/>
-          </a:bodyPr>
-          <a:lstStyle/>
-          <a:p>
-            <a:pPr algn="l"/>
-            <a:r>
-              <a:rPr sz="1100" b="0" i="0">
-                <a:solidFill>
-                  <a:srgbClr val="2166AC"/>
-                </a:solidFill>
-              </a:rPr>
-              <a:t>-&gt;</a:t>
-            </a:r>
-          </a:p>
-        </p:txBody>
-      </p:sp>
-      <p:sp>
-        <p:nvSpPr>
-          <p:cNvPr id="32" name="TextBox 31"/>
-          <p:cNvSpPr txBox="1"/>
-          <p:nvPr/>
-        </p:nvSpPr>
-        <p:spPr>
-          <a:xfrm>
-            <a:off x="731520" y="6373368"/>
-            <a:ext cx="10972800" cy="347472"/>
-          </a:xfrm>
-          <a:prstGeom prst="rect">
-            <a:avLst/>
-          </a:prstGeom>
-          <a:noFill/>
-        </p:spPr>
-        <p:txBody>
-          <a:bodyPr wrap="square">
-            <a:spAutoFit/>
-          </a:bodyPr>
-          <a:lstStyle/>
-          <a:p>
-            <a:pPr algn="l"/>
-            <a:r>
-              <a:rPr sz="1100" b="0" i="0">
-                <a:solidFill>
-                  <a:srgbClr val="444444"/>
-                </a:solidFill>
-              </a:rPr>
-              <a:t>   Ajouter comparaison avec donnees precliniques T-DXd si disponibles</a:t>
-            </a:r>
-          </a:p>
-        </p:txBody>
-      </p:sp>
-      <p:sp>
-        <p:nvSpPr>
-          <p:cNvPr id="33" name="TextBox 32"/>
-          <p:cNvSpPr txBox="1"/>
-          <p:nvPr/>
-        </p:nvSpPr>
-        <p:spPr>
-          <a:xfrm>
-            <a:off x="502920" y="6373368"/>
-            <a:ext cx="274320" cy="320040"/>
-          </a:xfrm>
-          <a:prstGeom prst="rect">
-            <a:avLst/>
-          </a:prstGeom>
-          <a:noFill/>
-        </p:spPr>
-        <p:txBody>
-          <a:bodyPr wrap="square">
-            <a:spAutoFit/>
-          </a:bodyPr>
-          <a:lstStyle/>
-          <a:p>
-            <a:pPr algn="l"/>
-            <a:r>
-              <a:rPr sz="1100" b="0" i="0">
-                <a:solidFill>
-                  <a:srgbClr val="2166AC"/>
-                </a:solidFill>
-              </a:rPr>
-              <a:t>-&gt;</a:t>
+              <a:t>Comparer nadirs Neut/Plt simules avec donnees precliniques T-DXd</a:t>
             </a:r>
           </a:p>
         </p:txBody>

</xml_diff>